<commit_message>
Add multi-region DR diagram example
</commit_message>
<xml_diff>
--- a/examples/ha-waf-dataguard.pptx
+++ b/examples/ha-waf-dataguard.pptx
@@ -723,8 +723,8 @@
         </p:nvSpPr>
         <p:spPr>
           <a:xfrm>
-            <a:off x="10689336" y="2496312"/>
-            <a:ext cx="704088" cy="246888"/>
+            <a:off x="10689336" y="2468880"/>
+            <a:ext cx="704088" cy="201168"/>
           </a:xfrm>
           <a:prstGeom prst="rect">
             <a:avLst/>
@@ -1231,8 +1231,8 @@
         </p:nvSpPr>
         <p:spPr>
           <a:xfrm>
-            <a:off x="18288" y="2825496"/>
-            <a:ext cx="1024128" cy="246888"/>
+            <a:off x="18288" y="2798064"/>
+            <a:ext cx="1024128" cy="201168"/>
           </a:xfrm>
           <a:prstGeom prst="rect">
             <a:avLst/>
@@ -1295,8 +1295,8 @@
         </p:nvSpPr>
         <p:spPr>
           <a:xfrm>
-            <a:off x="1019556" y="2852928"/>
-            <a:ext cx="960120" cy="246888"/>
+            <a:off x="1019556" y="2825496"/>
+            <a:ext cx="960120" cy="201168"/>
           </a:xfrm>
           <a:prstGeom prst="rect">
             <a:avLst/>
@@ -1343,7 +1343,7 @@
         </p:blipFill>
         <p:spPr>
           <a:xfrm>
-            <a:off x="1280160" y="4398264"/>
+            <a:off x="1280160" y="2916936"/>
             <a:ext cx="438912" cy="438912"/>
           </a:xfrm>
           <a:prstGeom prst="rect">
@@ -1359,8 +1359,8 @@
         </p:nvSpPr>
         <p:spPr>
           <a:xfrm>
-            <a:off x="1019556" y="4864608"/>
-            <a:ext cx="960120" cy="246888"/>
+            <a:off x="1019556" y="3355848"/>
+            <a:ext cx="960120" cy="201168"/>
           </a:xfrm>
           <a:prstGeom prst="rect">
             <a:avLst/>
@@ -1423,8 +1423,8 @@
         </p:nvSpPr>
         <p:spPr>
           <a:xfrm>
-            <a:off x="10149840" y="4864608"/>
-            <a:ext cx="566928" cy="246888"/>
+            <a:off x="10149840" y="4837176"/>
+            <a:ext cx="566928" cy="201168"/>
           </a:xfrm>
           <a:prstGeom prst="rect">
             <a:avLst/>
@@ -1487,8 +1487,8 @@
         </p:nvSpPr>
         <p:spPr>
           <a:xfrm>
-            <a:off x="2633472" y="2825496"/>
-            <a:ext cx="1529334" cy="246888"/>
+            <a:off x="2633472" y="2798064"/>
+            <a:ext cx="1529334" cy="201168"/>
           </a:xfrm>
           <a:prstGeom prst="rect">
             <a:avLst/>
@@ -1551,8 +1551,8 @@
         </p:nvSpPr>
         <p:spPr>
           <a:xfrm>
-            <a:off x="4162806" y="2825496"/>
-            <a:ext cx="1529334" cy="246888"/>
+            <a:off x="4162806" y="2798064"/>
+            <a:ext cx="1529334" cy="201168"/>
           </a:xfrm>
           <a:prstGeom prst="rect">
             <a:avLst/>
@@ -1615,8 +1615,8 @@
         </p:nvSpPr>
         <p:spPr>
           <a:xfrm>
-            <a:off x="2633472" y="4837176"/>
-            <a:ext cx="1019556" cy="246888"/>
+            <a:off x="2633472" y="4809744"/>
+            <a:ext cx="1019556" cy="201168"/>
           </a:xfrm>
           <a:prstGeom prst="rect">
             <a:avLst/>
@@ -1679,8 +1679,8 @@
         </p:nvSpPr>
         <p:spPr>
           <a:xfrm>
-            <a:off x="3653028" y="4837176"/>
-            <a:ext cx="1019556" cy="246888"/>
+            <a:off x="3653028" y="4809744"/>
+            <a:ext cx="1019556" cy="201168"/>
           </a:xfrm>
           <a:prstGeom prst="rect">
             <a:avLst/>
@@ -1743,8 +1743,8 @@
         </p:nvSpPr>
         <p:spPr>
           <a:xfrm>
-            <a:off x="4672584" y="4837176"/>
-            <a:ext cx="1019556" cy="246888"/>
+            <a:off x="4672584" y="4809744"/>
+            <a:ext cx="1019556" cy="201168"/>
           </a:xfrm>
           <a:prstGeom prst="rect">
             <a:avLst/>
@@ -1807,8 +1807,8 @@
         </p:nvSpPr>
         <p:spPr>
           <a:xfrm>
-            <a:off x="6478524" y="2825496"/>
-            <a:ext cx="1529334" cy="246888"/>
+            <a:off x="6478524" y="2798064"/>
+            <a:ext cx="1529334" cy="201168"/>
           </a:xfrm>
           <a:prstGeom prst="rect">
             <a:avLst/>
@@ -1871,8 +1871,8 @@
         </p:nvSpPr>
         <p:spPr>
           <a:xfrm>
-            <a:off x="8007858" y="2825496"/>
-            <a:ext cx="1529334" cy="246888"/>
+            <a:off x="8007858" y="2798064"/>
+            <a:ext cx="1529334" cy="201168"/>
           </a:xfrm>
           <a:prstGeom prst="rect">
             <a:avLst/>
@@ -1935,8 +1935,8 @@
         </p:nvSpPr>
         <p:spPr>
           <a:xfrm>
-            <a:off x="6478524" y="4837176"/>
-            <a:ext cx="1529334" cy="246888"/>
+            <a:off x="6478524" y="4809744"/>
+            <a:ext cx="1529334" cy="201168"/>
           </a:xfrm>
           <a:prstGeom prst="rect">
             <a:avLst/>
@@ -1999,8 +1999,8 @@
         </p:nvSpPr>
         <p:spPr>
           <a:xfrm>
-            <a:off x="8007858" y="4837176"/>
-            <a:ext cx="1529334" cy="246888"/>
+            <a:off x="8007858" y="4809744"/>
+            <a:ext cx="1529334" cy="201168"/>
           </a:xfrm>
           <a:prstGeom prst="rect">
             <a:avLst/>
@@ -2643,7 +2643,7 @@
                 <a:latin typeface="Aptos"/>
                 <a:ea typeface="Malgun Gothic"/>
               </a:rPr>
-              <a:t>- Only the DataGuard DB connection line and label are shown on the architecture slide for readability.</a:t>
+              <a:t>- Only VCN peering and the DataGuard DB connection line are shown on the architecture slide for readability.</a:t>
             </a:r>
             <a:endParaRPr lang="en-US" sz="919"/>
           </a:p>

</xml_diff>